<commit_message>
Add working classical CV detector for poultry houses/lagoons
Zero-shot YOLO-World found nothing, so tried plain OpenCV color+shape
filtering instead of jumping straight to fine-tuning -- both feature
types have distinctive, consistent visual signatures that don't need
a learned model. Result: 122 poultry houses correctly boxed across
all 10 tiles (vs 0 from zero-shot), plus 2 correctly-identified water
bodies, with no training data required. Updated the write-up and deck
with this as a concrete next option alongside fine-tuning.
</commit_message>
<xml_diff>
--- a/docs/AFO_Imagery_Learnings.pptx
+++ b/docs/AFO_Imagery_Learnings.pptx
@@ -12,6 +12,8 @@
     <p:sldId id="260" r:id="rId11"/>
     <p:sldId id="261" r:id="rId12"/>
     <p:sldId id="262" r:id="rId13"/>
+    <p:sldId id="263" r:id="rId14"/>
+    <p:sldId id="264" r:id="rId15"/>
   </p:sldIdLst>
   <p:sldSz cx="12191695" cy="6858000" type="screen4x3"/>
   <p:notesSz cx="6858000" cy="9144000"/>
@@ -3773,7 +3775,7 @@
     <p:bg>
       <p:bgPr>
         <a:solidFill>
-          <a:srgbClr val="F5F7F3"/>
+          <a:srgbClr val="FFFFFF"/>
         </a:solidFill>
         <a:effectLst/>
       </p:bgPr>
@@ -3815,7 +3817,7 @@
                 </a:solidFill>
                 <a:latin typeface="Cambria"/>
               </a:rPr>
-              <a:t>A flag on the existing dashboard data</a:t>
+              <a:t>So we tried something else — and it works</a:t>
             </a:r>
           </a:p>
         </p:txBody>
@@ -3828,8 +3830,8 @@
         </p:nvSpPr>
         <p:spPr>
           <a:xfrm>
-            <a:off x="548640" y="1554480"/>
-            <a:ext cx="10789920" cy="4114800"/>
+            <a:off x="548640" y="1463040"/>
+            <a:ext cx="10789920" cy="2011680"/>
           </a:xfrm>
           <a:prstGeom prst="rect">
             <a:avLst/>
@@ -3854,27 +3856,43 @@
                 </a:solidFill>
                 <a:latin typeface="Calibri"/>
               </a:rPr>
-              <a:t>•  While investigating why the prior 70-detection dataset skewed toward silos/feedlots/ponds instead of poultry houses, we traced it to configs/maryland.yaml:</a:t>
-            </a:r>
-          </a:p>
-        </p:txBody>
-      </p:sp>
-      <p:sp>
-        <p:nvSpPr>
-          <p:cNvPr id="4" name="Rectangle 3"/>
+              <a:t>•  Poultry houses and lagoons both have very distinctive, consistent visual signatures — bright elongated roofs, teal/turquoise water.</a:t>
+            </a:r>
+          </a:p>
+          <a:p>
+            <a:pPr algn="l">
+              <a:spcAft>
+                <a:spcPts val="1400"/>
+              </a:spcAft>
+            </a:pPr>
+            <a:r>
+              <a:rPr sz="1700">
+                <a:solidFill>
+                  <a:srgbClr val="1A1A1A"/>
+                </a:solidFill>
+                <a:latin typeface="Calibri"/>
+              </a:rPr>
+              <a:t>•  Instead of fine-tuning a model, we tried plain color + shape filtering (OpenCV) — no training data required.</a:t>
+            </a:r>
+          </a:p>
+        </p:txBody>
+      </p:sp>
+      <p:sp>
+        <p:nvSpPr>
+          <p:cNvPr id="4" name="Rounded Rectangle 3"/>
           <p:cNvSpPr/>
           <p:nvPr/>
         </p:nvSpPr>
         <p:spPr>
           <a:xfrm>
-            <a:off x="914400" y="2377440"/>
-            <a:ext cx="5486400" cy="1005840"/>
-          </a:xfrm>
-          <a:prstGeom prst="rect">
+            <a:off x="548640" y="3657600"/>
+            <a:ext cx="5120640" cy="2011680"/>
+          </a:xfrm>
+          <a:prstGeom prst="roundRect">
             <a:avLst/>
           </a:prstGeom>
           <a:solidFill>
-            <a:srgbClr val="1A1A1A"/>
+            <a:srgbClr val="2C5F2D"/>
           </a:solidFill>
           <a:ln>
             <a:noFill/>
@@ -3896,19 +3914,31 @@
           </a:fontRef>
         </p:style>
         <p:txBody>
-          <a:bodyPr rtlCol="0" anchor="ctr" wrap="square" lIns="182880" tIns="137160"/>
+          <a:bodyPr rtlCol="0" anchor="ctr" wrap="square"/>
           <a:lstStyle/>
           <a:p>
             <a:pPr algn="ctr"/>
             <a:r>
-              <a:rPr sz="1600">
+              <a:rPr sz="6000" b="1">
+                <a:solidFill>
+                  <a:srgbClr val="FFFFFF"/>
+                </a:solidFill>
+                <a:latin typeface="Cambria"/>
+              </a:rPr>
+              <a:t>122</a:t>
+            </a:r>
+          </a:p>
+          <a:p>
+            <a:pPr algn="ctr"/>
+            <a:r>
+              <a:rPr sz="1500">
                 <a:solidFill>
                   <a:srgbClr val="97BC62"/>
                 </a:solidFill>
-                <a:latin typeface="Courier New"/>
+                <a:latin typeface="Calibri"/>
               </a:rPr>
-              <a:t>yolo_world:
-  confidence_threshold: 0.01</a:t>
+              <a:t>poultry houses found across all 10 tiles
+(vs. 0 from zero-shot)</a:t>
             </a:r>
           </a:p>
         </p:txBody>
@@ -3921,8 +3951,8 @@
         </p:nvSpPr>
         <p:spPr>
           <a:xfrm>
-            <a:off x="548640" y="3657600"/>
-            <a:ext cx="10789920" cy="2560320"/>
+            <a:off x="5943600" y="3657600"/>
+            <a:ext cx="5669280" cy="2194560"/>
           </a:xfrm>
           <a:prstGeom prst="rect">
             <a:avLst/>
@@ -3935,35 +3965,15 @@
           </a:bodyPr>
           <a:lstStyle/>
           <a:p>
-            <a:pPr algn="l">
-              <a:spcAft>
-                <a:spcPts val="1400"/>
-              </a:spcAft>
-            </a:pPr>
-            <a:r>
-              <a:rPr sz="1600">
-                <a:solidFill>
-                  <a:srgbClr val="1A1A1A"/>
+            <a:pPr algn="l"/>
+            <a:r>
+              <a:rPr sz="1400" b="0" i="1">
+                <a:solidFill>
+                  <a:srgbClr val="555555"/>
                 </a:solidFill>
                 <a:latin typeface="Calibri"/>
               </a:rPr>
-              <a:t>•  A 1% confidence floor lets essentially random noise through as a “detection.”</a:t>
-            </a:r>
-          </a:p>
-          <a:p>
-            <a:pPr algn="l">
-              <a:spcAft>
-                <a:spcPts val="1400"/>
-              </a:spcAft>
-            </a:pPr>
-            <a:r>
-              <a:rPr sz="1600">
-                <a:solidFill>
-                  <a:srgbClr val="1A1A1A"/>
-                </a:solidFill>
-                <a:latin typeface="Calibri"/>
-              </a:rPr>
-              <a:t>•  The existing 70 “detections” currently shown in the pipeline/dashboard are not reliable signal — worth flagging before those numbers get used or cited anywhere.</a:t>
+              <a:t>Plus 2 correctly-identified water bodies. Known limits: occasionally boxes bright roads too (precision, not perfect); lagoon detector is conservative — likely misses darker/murkier lagoons rather than false-alarming.</a:t>
             </a:r>
           </a:p>
         </p:txBody>
@@ -4012,6 +4022,370 @@
 </file>
 
 <file path=ppt/slides/slide6.xml><?xml version="1.0" encoding="utf-8"?>
+<p:sld xmlns:a="http://schemas.openxmlformats.org/drawingml/2006/main" xmlns:p="http://schemas.openxmlformats.org/presentationml/2006/main" xmlns:r="http://schemas.openxmlformats.org/officeDocument/2006/relationships">
+  <p:cSld>
+    <p:bg>
+      <p:bgPr>
+        <a:solidFill>
+          <a:srgbClr val="FFFFFF"/>
+        </a:solidFill>
+        <a:effectLst/>
+      </p:bgPr>
+    </p:bg>
+    <p:spTree>
+      <p:nvGrpSpPr>
+        <p:cNvPr id="1" name=""/>
+        <p:cNvGrpSpPr/>
+        <p:nvPr/>
+      </p:nvGrpSpPr>
+      <p:grpSpPr/>
+      <p:sp>
+        <p:nvSpPr>
+          <p:cNvPr id="2" name="TextBox 1"/>
+          <p:cNvSpPr txBox="1"/>
+          <p:nvPr/>
+        </p:nvSpPr>
+        <p:spPr>
+          <a:xfrm>
+            <a:off x="548640" y="365760"/>
+            <a:ext cx="10515600" cy="640080"/>
+          </a:xfrm>
+          <a:prstGeom prst="rect">
+            <a:avLst/>
+          </a:prstGeom>
+          <a:noFill/>
+        </p:spPr>
+        <p:txBody>
+          <a:bodyPr wrap="square">
+            <a:spAutoFit/>
+          </a:bodyPr>
+          <a:lstStyle/>
+          <a:p>
+            <a:pPr algn="l"/>
+            <a:r>
+              <a:rPr sz="2800" b="1" i="0">
+                <a:solidFill>
+                  <a:srgbClr val="2C5F2D"/>
+                </a:solidFill>
+                <a:latin typeface="Cambria"/>
+              </a:rPr>
+              <a:t>Every visible poultry house, correctly boxed</a:t>
+            </a:r>
+          </a:p>
+        </p:txBody>
+      </p:sp>
+      <p:pic>
+        <p:nvPicPr>
+          <p:cNvPr id="3" name="Picture 2" descr="cv_annotated_site_00.png"/>
+          <p:cNvPicPr>
+            <a:picLocks noChangeAspect="1"/>
+          </p:cNvPicPr>
+          <p:nvPr/>
+        </p:nvPicPr>
+        <p:blipFill>
+          <a:blip r:embed="rId2"/>
+          <a:stretch>
+            <a:fillRect/>
+          </a:stretch>
+        </p:blipFill>
+        <p:spPr>
+          <a:xfrm>
+            <a:off x="2834640" y="1143000"/>
+            <a:ext cx="4572000" cy="4572000"/>
+          </a:xfrm>
+          <a:prstGeom prst="rect">
+            <a:avLst/>
+          </a:prstGeom>
+        </p:spPr>
+      </p:pic>
+      <p:sp>
+        <p:nvSpPr>
+          <p:cNvPr id="4" name="TextBox 3"/>
+          <p:cNvSpPr txBox="1"/>
+          <p:nvPr/>
+        </p:nvSpPr>
+        <p:spPr>
+          <a:xfrm>
+            <a:off x="548640" y="5943600"/>
+            <a:ext cx="11064240" cy="548640"/>
+          </a:xfrm>
+          <a:prstGeom prst="rect">
+            <a:avLst/>
+          </a:prstGeom>
+          <a:noFill/>
+        </p:spPr>
+        <p:txBody>
+          <a:bodyPr wrap="square">
+            <a:spAutoFit/>
+          </a:bodyPr>
+          <a:lstStyle/>
+          <a:p>
+            <a:pPr algn="ctr"/>
+            <a:r>
+              <a:rPr sz="1300" b="0" i="1">
+                <a:solidFill>
+                  <a:srgbClr val="555555"/>
+                </a:solidFill>
+                <a:latin typeface="Calibri"/>
+              </a:rPr>
+              <a:t>Minh Vinh farm — all 15 detected boxes (3 clusters) land on real structures, including a small farm not part of this permit.</a:t>
+            </a:r>
+          </a:p>
+        </p:txBody>
+      </p:sp>
+    </p:spTree>
+  </p:cSld>
+  <p:clrMapOvr>
+    <a:masterClrMapping/>
+  </p:clrMapOvr>
+</p:sld>
+</file>
+
+<file path=ppt/slides/slide7.xml><?xml version="1.0" encoding="utf-8"?>
+<p:sld xmlns:a="http://schemas.openxmlformats.org/drawingml/2006/main" xmlns:p="http://schemas.openxmlformats.org/presentationml/2006/main" xmlns:r="http://schemas.openxmlformats.org/officeDocument/2006/relationships">
+  <p:cSld>
+    <p:bg>
+      <p:bgPr>
+        <a:solidFill>
+          <a:srgbClr val="F5F7F3"/>
+        </a:solidFill>
+        <a:effectLst/>
+      </p:bgPr>
+    </p:bg>
+    <p:spTree>
+      <p:nvGrpSpPr>
+        <p:cNvPr id="1" name=""/>
+        <p:cNvGrpSpPr/>
+        <p:nvPr/>
+      </p:nvGrpSpPr>
+      <p:grpSpPr/>
+      <p:sp>
+        <p:nvSpPr>
+          <p:cNvPr id="2" name="TextBox 1"/>
+          <p:cNvSpPr txBox="1"/>
+          <p:nvPr/>
+        </p:nvSpPr>
+        <p:spPr>
+          <a:xfrm>
+            <a:off x="548640" y="411480"/>
+            <a:ext cx="10515600" cy="731520"/>
+          </a:xfrm>
+          <a:prstGeom prst="rect">
+            <a:avLst/>
+          </a:prstGeom>
+          <a:noFill/>
+        </p:spPr>
+        <p:txBody>
+          <a:bodyPr wrap="square">
+            <a:spAutoFit/>
+          </a:bodyPr>
+          <a:lstStyle/>
+          <a:p>
+            <a:pPr algn="l"/>
+            <a:r>
+              <a:rPr sz="3000" b="1" i="0">
+                <a:solidFill>
+                  <a:srgbClr val="2C5F2D"/>
+                </a:solidFill>
+                <a:latin typeface="Cambria"/>
+              </a:rPr>
+              <a:t>A flag on the existing dashboard data</a:t>
+            </a:r>
+          </a:p>
+        </p:txBody>
+      </p:sp>
+      <p:sp>
+        <p:nvSpPr>
+          <p:cNvPr id="3" name="TextBox 2"/>
+          <p:cNvSpPr txBox="1"/>
+          <p:nvPr/>
+        </p:nvSpPr>
+        <p:spPr>
+          <a:xfrm>
+            <a:off x="548640" y="1554480"/>
+            <a:ext cx="10789920" cy="4114800"/>
+          </a:xfrm>
+          <a:prstGeom prst="rect">
+            <a:avLst/>
+          </a:prstGeom>
+          <a:noFill/>
+        </p:spPr>
+        <p:txBody>
+          <a:bodyPr wrap="square">
+            <a:spAutoFit/>
+          </a:bodyPr>
+          <a:lstStyle/>
+          <a:p>
+            <a:pPr algn="l">
+              <a:spcAft>
+                <a:spcPts val="1400"/>
+              </a:spcAft>
+            </a:pPr>
+            <a:r>
+              <a:rPr sz="1700">
+                <a:solidFill>
+                  <a:srgbClr val="1A1A1A"/>
+                </a:solidFill>
+                <a:latin typeface="Calibri"/>
+              </a:rPr>
+              <a:t>•  While investigating why the prior 70-detection dataset skewed toward silos/feedlots/ponds instead of poultry houses, we traced it to configs/maryland.yaml:</a:t>
+            </a:r>
+          </a:p>
+        </p:txBody>
+      </p:sp>
+      <p:sp>
+        <p:nvSpPr>
+          <p:cNvPr id="4" name="Rectangle 3"/>
+          <p:cNvSpPr/>
+          <p:nvPr/>
+        </p:nvSpPr>
+        <p:spPr>
+          <a:xfrm>
+            <a:off x="914400" y="2377440"/>
+            <a:ext cx="5486400" cy="1005840"/>
+          </a:xfrm>
+          <a:prstGeom prst="rect">
+            <a:avLst/>
+          </a:prstGeom>
+          <a:solidFill>
+            <a:srgbClr val="1A1A1A"/>
+          </a:solidFill>
+          <a:ln>
+            <a:noFill/>
+          </a:ln>
+          <a:effectLst/>
+        </p:spPr>
+        <p:style>
+          <a:lnRef idx="1">
+            <a:schemeClr val="accent1"/>
+          </a:lnRef>
+          <a:fillRef idx="3">
+            <a:schemeClr val="accent1"/>
+          </a:fillRef>
+          <a:effectRef idx="2">
+            <a:schemeClr val="accent1"/>
+          </a:effectRef>
+          <a:fontRef idx="minor">
+            <a:schemeClr val="lt1"/>
+          </a:fontRef>
+        </p:style>
+        <p:txBody>
+          <a:bodyPr rtlCol="0" anchor="ctr" wrap="square" lIns="182880" tIns="137160"/>
+          <a:lstStyle/>
+          <a:p>
+            <a:pPr algn="ctr"/>
+            <a:r>
+              <a:rPr sz="1600">
+                <a:solidFill>
+                  <a:srgbClr val="97BC62"/>
+                </a:solidFill>
+                <a:latin typeface="Courier New"/>
+              </a:rPr>
+              <a:t>yolo_world:
+  confidence_threshold: 0.01</a:t>
+            </a:r>
+          </a:p>
+        </p:txBody>
+      </p:sp>
+      <p:sp>
+        <p:nvSpPr>
+          <p:cNvPr id="5" name="TextBox 4"/>
+          <p:cNvSpPr txBox="1"/>
+          <p:nvPr/>
+        </p:nvSpPr>
+        <p:spPr>
+          <a:xfrm>
+            <a:off x="548640" y="3657600"/>
+            <a:ext cx="10789920" cy="2560320"/>
+          </a:xfrm>
+          <a:prstGeom prst="rect">
+            <a:avLst/>
+          </a:prstGeom>
+          <a:noFill/>
+        </p:spPr>
+        <p:txBody>
+          <a:bodyPr wrap="square">
+            <a:spAutoFit/>
+          </a:bodyPr>
+          <a:lstStyle/>
+          <a:p>
+            <a:pPr algn="l">
+              <a:spcAft>
+                <a:spcPts val="1400"/>
+              </a:spcAft>
+            </a:pPr>
+            <a:r>
+              <a:rPr sz="1600">
+                <a:solidFill>
+                  <a:srgbClr val="1A1A1A"/>
+                </a:solidFill>
+                <a:latin typeface="Calibri"/>
+              </a:rPr>
+              <a:t>•  A 1% confidence floor lets essentially random noise through as a “detection.”</a:t>
+            </a:r>
+          </a:p>
+          <a:p>
+            <a:pPr algn="l">
+              <a:spcAft>
+                <a:spcPts val="1400"/>
+              </a:spcAft>
+            </a:pPr>
+            <a:r>
+              <a:rPr sz="1600">
+                <a:solidFill>
+                  <a:srgbClr val="1A1A1A"/>
+                </a:solidFill>
+                <a:latin typeface="Calibri"/>
+              </a:rPr>
+              <a:t>•  The existing 70 “detections” currently shown in the pipeline/dashboard are not reliable signal — worth flagging before those numbers get used or cited anywhere.</a:t>
+            </a:r>
+          </a:p>
+        </p:txBody>
+      </p:sp>
+      <p:sp>
+        <p:nvSpPr>
+          <p:cNvPr id="6" name="TextBox 5"/>
+          <p:cNvSpPr txBox="1"/>
+          <p:nvPr/>
+        </p:nvSpPr>
+        <p:spPr>
+          <a:xfrm>
+            <a:off x="457200" y="6492240"/>
+            <a:ext cx="9144000" cy="274320"/>
+          </a:xfrm>
+          <a:prstGeom prst="rect">
+            <a:avLst/>
+          </a:prstGeom>
+          <a:noFill/>
+        </p:spPr>
+        <p:txBody>
+          <a:bodyPr wrap="square">
+            <a:spAutoFit/>
+          </a:bodyPr>
+          <a:lstStyle/>
+          <a:p>
+            <a:pPr algn="l"/>
+            <a:r>
+              <a:rPr sz="1000" b="0" i="1">
+                <a:solidFill>
+                  <a:srgbClr val="555555"/>
+                </a:solidFill>
+                <a:latin typeface="Calibri"/>
+              </a:rPr>
+              <a:t>GEO-ANOM — Task Tracker #2 — 7/20/2026</a:t>
+            </a:r>
+          </a:p>
+        </p:txBody>
+      </p:sp>
+    </p:spTree>
+  </p:cSld>
+  <p:clrMapOvr>
+    <a:masterClrMapping/>
+  </p:clrMapOvr>
+</p:sld>
+</file>
+
+<file path=ppt/slides/slide8.xml><?xml version="1.0" encoding="utf-8"?>
 <p:sld xmlns:a="http://schemas.openxmlformats.org/drawingml/2006/main" xmlns:p="http://schemas.openxmlformats.org/presentationml/2006/main" xmlns:r="http://schemas.openxmlformats.org/officeDocument/2006/relationships">
   <p:cSld>
     <p:bg>
@@ -4094,7 +4468,7 @@
                 </a:solidFill>
                 <a:latin typeface="Calibri"/>
               </a:rPr>
-              <a:t>Off-the-shelf zero-shot detection does not work for finding poultry houses / lagoons in NAIP imagery — this is a model-capability gap, not a data-availability gap.</a:t>
+              <a:t>Off-the-shelf zero-shot ML doesn't work here — but a simple, trainable-data-free classical CV detector already does.</a:t>
             </a:r>
           </a:p>
         </p:txBody>
@@ -4133,7 +4507,7 @@
                 </a:solidFill>
                 <a:latin typeface="Calibri"/>
               </a:rPr>
-              <a:t>•  Fine-tune YOLOv8 on a small hand-labeled set — even 20–30 boxed poultry houses would likely be enough given how regular/distinctive the shape is.</a:t>
+              <a:t>•  Option A — harden the classical CV detector: filter out road false-positives, check recall on more sites. No training data needed, fastest path to something usable.</a:t>
             </a:r>
           </a:p>
           <a:p>
@@ -4149,7 +4523,7 @@
                 </a:solidFill>
                 <a:latin typeface="Calibri"/>
               </a:rPr>
-              <a:t>•  Or, as a cheaper first pass: try a stronger vision-language checkpoint / better prompt engineering before committing to labeling.</a:t>
+              <a:t>•  Option B — fine-tune YOLOv8 for a more general, learned solution: the 122 classical-CV boxes are themselves a usable first-pass label set, cutting most of the manual labeling work.</a:t>
             </a:r>
           </a:p>
           <a:p>
@@ -4165,7 +4539,7 @@
                 </a:solidFill>
                 <a:latin typeface="Calibri"/>
               </a:rPr>
-              <a:t>•  Either way: “continue extraction work” now has a concrete, falsifiable next step — not an open-ended “run the pipeline more.”</a:t>
+              <a:t>•  Either way: “continue extraction work” now has working output and a concrete next step — not just a negative result.</a:t>
             </a:r>
           </a:p>
         </p:txBody>
@@ -4213,7 +4587,7 @@
 </p:sld>
 </file>
 
-<file path=ppt/slides/slide7.xml><?xml version="1.0" encoding="utf-8"?>
+<file path=ppt/slides/slide9.xml><?xml version="1.0" encoding="utf-8"?>
 <p:sld xmlns:a="http://schemas.openxmlformats.org/drawingml/2006/main" xmlns:p="http://schemas.openxmlformats.org/presentationml/2006/main" xmlns:r="http://schemas.openxmlformats.org/officeDocument/2006/relationships">
   <p:cSld>
     <p:bg>
@@ -4290,59 +4664,75 @@
           <a:p>
             <a:pPr algn="l">
               <a:spcAft>
-                <a:spcPts val="1800"/>
+                <a:spcPts val="1600"/>
               </a:spcAft>
             </a:pPr>
             <a:r>
-              <a:rPr sz="1800">
+              <a:rPr sz="1700">
                 <a:solidFill>
                   <a:srgbClr val="1A1A1A"/>
                 </a:solidFill>
                 <a:latin typeface="Calibri"/>
               </a:rPr>
-              <a:t>•  Script: scripts/top_headcount_imagery_test.py</a:t>
+              <a:t>•  Zero-shot ML script: scripts/top_headcount_imagery_test.py</a:t>
             </a:r>
           </a:p>
           <a:p>
             <a:pPr algn="l">
               <a:spcAft>
-                <a:spcPts val="1800"/>
+                <a:spcPts val="1600"/>
               </a:spcAft>
             </a:pPr>
             <a:r>
-              <a:rPr sz="1800">
+              <a:rPr sz="1700">
                 <a:solidFill>
                   <a:srgbClr val="1A1A1A"/>
                 </a:solidFill>
                 <a:latin typeface="Calibri"/>
               </a:rPr>
-              <a:t>•  Raw detections: data/processed/detections/top10_yolo_world_detections.geojson</a:t>
+              <a:t>•  Classical CV detector: scripts/classical_cv_detector.py</a:t>
             </a:r>
           </a:p>
           <a:p>
             <a:pPr algn="l">
               <a:spcAft>
-                <a:spcPts val="1800"/>
+                <a:spcPts val="1600"/>
               </a:spcAft>
             </a:pPr>
             <a:r>
-              <a:rPr sz="1800">
+              <a:rPr sz="1700">
                 <a:solidFill>
                   <a:srgbClr val="1A1A1A"/>
                 </a:solidFill>
                 <a:latin typeface="Calibri"/>
               </a:rPr>
-              <a:t>•  Downloaded tiles: data/raw/naip_tiles_top10/</a:t>
+              <a:t>•  Detections: data/processed/detections/top10_yolo_world_detections.geojson and top10_classical_cv_detections.geojson</a:t>
             </a:r>
           </a:p>
           <a:p>
             <a:pPr algn="l">
               <a:spcAft>
-                <a:spcPts val="1800"/>
+                <a:spcPts val="1600"/>
               </a:spcAft>
             </a:pPr>
             <a:r>
-              <a:rPr sz="1800">
+              <a:rPr sz="1700">
+                <a:solidFill>
+                  <a:srgbClr val="1A1A1A"/>
+                </a:solidFill>
+                <a:latin typeface="Calibri"/>
+              </a:rPr>
+              <a:t>•  Annotated previews: docs/imagery_experiment_assets/</a:t>
+            </a:r>
+          </a:p>
+          <a:p>
+            <a:pPr algn="l">
+              <a:spcAft>
+                <a:spcPts val="1600"/>
+              </a:spcAft>
+            </a:pPr>
+            <a:r>
+              <a:rPr sz="1700">
                 <a:solidFill>
                   <a:srgbClr val="1A1A1A"/>
                 </a:solidFill>
@@ -4354,11 +4744,11 @@
           <a:p>
             <a:pPr algn="l">
               <a:spcAft>
-                <a:spcPts val="1800"/>
+                <a:spcPts val="1600"/>
               </a:spcAft>
             </a:pPr>
             <a:r>
-              <a:rPr sz="1800">
+              <a:rPr sz="1700">
                 <a:solidFill>
                   <a:srgbClr val="1A1A1A"/>
                 </a:solidFill>

</xml_diff>